<commit_message>
updated day0 slide deck
</commit_message>
<xml_diff>
--- a/day0_wynton/intro_to_wynton_slides.pptx
+++ b/day0_wynton/intro_to_wynton_slides.pptx
@@ -226,7 +226,7 @@
           <a:p>
             <a:fld id="{018CEA7E-D73A-5C4F-B83E-D444CAD90BC0}" type="datetimeFigureOut">
               <a:rPr lang="en-US" smtClean="0"/>
-              <a:t>9/8/25</a:t>
+              <a:t>7/4/26</a:t>
             </a:fld>
             <a:endParaRPr lang="en-US"/>
           </a:p>
@@ -1832,7 +1832,7 @@
           <a:p>
             <a:fld id="{823D5D2F-9012-8E4C-9CF3-F8777AE66A9B}" type="datetimeFigureOut">
               <a:rPr lang="en-US" smtClean="0"/>
-              <a:t>9/8/25</a:t>
+              <a:t>7/4/26</a:t>
             </a:fld>
             <a:endParaRPr lang="en-US"/>
           </a:p>
@@ -2030,7 +2030,7 @@
           <a:p>
             <a:fld id="{823D5D2F-9012-8E4C-9CF3-F8777AE66A9B}" type="datetimeFigureOut">
               <a:rPr lang="en-US" smtClean="0"/>
-              <a:t>9/8/25</a:t>
+              <a:t>7/4/26</a:t>
             </a:fld>
             <a:endParaRPr lang="en-US"/>
           </a:p>
@@ -2238,7 +2238,7 @@
           <a:p>
             <a:fld id="{823D5D2F-9012-8E4C-9CF3-F8777AE66A9B}" type="datetimeFigureOut">
               <a:rPr lang="en-US" smtClean="0"/>
-              <a:t>9/8/25</a:t>
+              <a:t>7/4/26</a:t>
             </a:fld>
             <a:endParaRPr lang="en-US"/>
           </a:p>
@@ -2436,7 +2436,7 @@
           <a:p>
             <a:fld id="{823D5D2F-9012-8E4C-9CF3-F8777AE66A9B}" type="datetimeFigureOut">
               <a:rPr lang="en-US" smtClean="0"/>
-              <a:t>9/8/25</a:t>
+              <a:t>7/4/26</a:t>
             </a:fld>
             <a:endParaRPr lang="en-US"/>
           </a:p>
@@ -2711,7 +2711,7 @@
           <a:p>
             <a:fld id="{823D5D2F-9012-8E4C-9CF3-F8777AE66A9B}" type="datetimeFigureOut">
               <a:rPr lang="en-US" smtClean="0"/>
-              <a:t>9/8/25</a:t>
+              <a:t>7/4/26</a:t>
             </a:fld>
             <a:endParaRPr lang="en-US"/>
           </a:p>
@@ -2976,7 +2976,7 @@
           <a:p>
             <a:fld id="{823D5D2F-9012-8E4C-9CF3-F8777AE66A9B}" type="datetimeFigureOut">
               <a:rPr lang="en-US" smtClean="0"/>
-              <a:t>9/8/25</a:t>
+              <a:t>7/4/26</a:t>
             </a:fld>
             <a:endParaRPr lang="en-US"/>
           </a:p>
@@ -3388,7 +3388,7 @@
           <a:p>
             <a:fld id="{823D5D2F-9012-8E4C-9CF3-F8777AE66A9B}" type="datetimeFigureOut">
               <a:rPr lang="en-US" smtClean="0"/>
-              <a:t>9/8/25</a:t>
+              <a:t>7/4/26</a:t>
             </a:fld>
             <a:endParaRPr lang="en-US"/>
           </a:p>
@@ -3529,7 +3529,7 @@
           <a:p>
             <a:fld id="{823D5D2F-9012-8E4C-9CF3-F8777AE66A9B}" type="datetimeFigureOut">
               <a:rPr lang="en-US" smtClean="0"/>
-              <a:t>9/8/25</a:t>
+              <a:t>7/4/26</a:t>
             </a:fld>
             <a:endParaRPr lang="en-US"/>
           </a:p>
@@ -3642,7 +3642,7 @@
           <a:p>
             <a:fld id="{823D5D2F-9012-8E4C-9CF3-F8777AE66A9B}" type="datetimeFigureOut">
               <a:rPr lang="en-US" smtClean="0"/>
-              <a:t>9/8/25</a:t>
+              <a:t>7/4/26</a:t>
             </a:fld>
             <a:endParaRPr lang="en-US"/>
           </a:p>
@@ -3953,7 +3953,7 @@
           <a:p>
             <a:fld id="{823D5D2F-9012-8E4C-9CF3-F8777AE66A9B}" type="datetimeFigureOut">
               <a:rPr lang="en-US" smtClean="0"/>
-              <a:t>9/8/25</a:t>
+              <a:t>7/4/26</a:t>
             </a:fld>
             <a:endParaRPr lang="en-US"/>
           </a:p>
@@ -4241,7 +4241,7 @@
           <a:p>
             <a:fld id="{823D5D2F-9012-8E4C-9CF3-F8777AE66A9B}" type="datetimeFigureOut">
               <a:rPr lang="en-US" smtClean="0"/>
-              <a:t>9/8/25</a:t>
+              <a:t>7/4/26</a:t>
             </a:fld>
             <a:endParaRPr lang="en-US"/>
           </a:p>
@@ -4482,7 +4482,7 @@
           <a:p>
             <a:fld id="{823D5D2F-9012-8E4C-9CF3-F8777AE66A9B}" type="datetimeFigureOut">
               <a:rPr lang="en-US" smtClean="0"/>
-              <a:t>9/8/25</a:t>
+              <a:t>7/4/26</a:t>
             </a:fld>
             <a:endParaRPr lang="en-US"/>
           </a:p>
@@ -4950,7 +4950,7 @@
           <a:p>
             <a:r>
               <a:rPr lang="en-US" dirty="0"/>
-              <a:t>Yulia Gutierrez</a:t>
+              <a:t>Beau Lonnquist</a:t>
             </a:r>
           </a:p>
           <a:p>
@@ -6580,7 +6580,9 @@
           </a:xfrm>
         </p:spPr>
         <p:txBody>
-          <a:bodyPr/>
+          <a:bodyPr>
+            <a:normAutofit/>
+          </a:bodyPr>
           <a:lstStyle/>
           <a:p>
             <a:pPr marL="0" indent="0">
@@ -6590,6 +6592,45 @@
               <a:rPr lang="en-US" dirty="0"/>
               <a:t>Login into Wynton and submit basic job </a:t>
             </a:r>
+          </a:p>
+          <a:p>
+            <a:pPr marL="0" indent="0">
+              <a:buNone/>
+            </a:pPr>
+            <a:r>
+              <a:rPr lang="en-US" b="1" dirty="0">
+                <a:hlinkClick r:id="rId2"/>
+              </a:rPr>
+              <a:t>https://github.com/blonn25/intro_to_programming_2026/blob/main/day0_wynton/day0_wynton.md</a:t>
+            </a:r>
+            <a:endParaRPr lang="en-US" b="1" dirty="0"/>
+          </a:p>
+          <a:p>
+            <a:pPr marL="0" indent="0">
+              <a:buNone/>
+            </a:pPr>
+            <a:endParaRPr lang="en-US" b="1" dirty="0"/>
+          </a:p>
+          <a:p>
+            <a:pPr marL="0" indent="0">
+              <a:buNone/>
+            </a:pPr>
+            <a:r>
+              <a:rPr lang="en-US" dirty="0"/>
+              <a:t>Can also generate private-public key pair to login without a password</a:t>
+            </a:r>
+          </a:p>
+          <a:p>
+            <a:pPr marL="0" indent="0">
+              <a:buNone/>
+            </a:pPr>
+            <a:r>
+              <a:rPr lang="en-US" b="1" dirty="0">
+                <a:hlinkClick r:id="rId3"/>
+              </a:rPr>
+              <a:t>https://wynton.ucsf.edu/hpc/howto/log-in-without-pwd.html</a:t>
+            </a:r>
+            <a:endParaRPr lang="en-US" b="1" dirty="0"/>
           </a:p>
           <a:p>
             <a:pPr marL="0" indent="0">
@@ -6601,37 +6642,16 @@
             <a:pPr marL="0" indent="0">
               <a:buNone/>
             </a:pPr>
-            <a:r>
-              <a:rPr lang="en-US" b="1" dirty="0">
-                <a:hlinkClick r:id="rId2"/>
-              </a:rPr>
-              <a:t>https://tinyurl.com/wynton25</a:t>
-            </a:r>
-            <a:endParaRPr lang="en-US" b="1" dirty="0"/>
-          </a:p>
-          <a:p>
-            <a:pPr marL="0" indent="0">
-              <a:buNone/>
-            </a:pPr>
-            <a:endParaRPr lang="en-US" b="1" dirty="0"/>
-          </a:p>
-          <a:p>
-            <a:pPr marL="0" indent="0">
-              <a:buNone/>
-            </a:pPr>
-            <a:r>
-              <a:rPr lang="en-US" dirty="0"/>
-              <a:t>Can also generate private-public key pair </a:t>
-            </a:r>
+            <a:endParaRPr lang="en-US" dirty="0"/>
           </a:p>
         </p:txBody>
       </p:sp>
       <p:pic>
         <p:nvPicPr>
-          <p:cNvPr id="5" name="Picture 4">
-            <a:extLst>
-              <a:ext uri="{FF2B5EF4-FFF2-40B4-BE49-F238E27FC236}">
-                <a16:creationId xmlns:a16="http://schemas.microsoft.com/office/drawing/2014/main" id="{51796956-6C17-844E-8F37-5E365F3FF0CF}"/>
+          <p:cNvPr id="7" name="Picture 6">
+            <a:extLst>
+              <a:ext uri="{FF2B5EF4-FFF2-40B4-BE49-F238E27FC236}">
+                <a16:creationId xmlns:a16="http://schemas.microsoft.com/office/drawing/2014/main" id="{648092E3-5125-C7D8-181F-6CCC2DD373F1}"/>
               </a:ext>
             </a:extLst>
           </p:cNvPr>
@@ -6641,15 +6661,15 @@
           <p:nvPr/>
         </p:nvPicPr>
         <p:blipFill>
-          <a:blip r:embed="rId3"/>
+          <a:blip r:embed="rId4"/>
           <a:stretch>
             <a:fillRect/>
           </a:stretch>
         </p:blipFill>
         <p:spPr>
           <a:xfrm>
-            <a:off x="7130974" y="1825625"/>
-            <a:ext cx="4084197" cy="4092850"/>
+            <a:off x="7607300" y="1825625"/>
+            <a:ext cx="3746500" cy="3733800"/>
           </a:xfrm>
           <a:prstGeom prst="rect">
             <a:avLst/>

</xml_diff>